<commit_message>
Merge Phase 5: Nâng cấp AI Supabase Vector RAG
</commit_message>
<xml_diff>
--- a/data/news/06.pptx
+++ b/data/news/06.pptx
@@ -6,7 +6,6 @@
   </p:sldMasterIdLst>
   <p:sldIdLst>
     <p:sldId id="256" r:id="rId2"/>
-    <p:sldId id="258" r:id="rId3"/>
   </p:sldIdLst>
   <p:sldSz cx="12192000" cy="6858000"/>
   <p:notesSz cx="6858000" cy="9144000"/>
@@ -260,7 +259,7 @@
           <a:p>
             <a:fld id="{76FC17FB-DA9F-457F-9F52-1E6CF5688C4E}" type="datetimeFigureOut">
               <a:rPr lang="en-US" smtClean="0"/>
-              <a:t>3/1/2026</a:t>
+              <a:t>3/2/2026</a:t>
             </a:fld>
             <a:endParaRPr lang="en-US"/>
           </a:p>
@@ -458,7 +457,7 @@
           <a:p>
             <a:fld id="{76FC17FB-DA9F-457F-9F52-1E6CF5688C4E}" type="datetimeFigureOut">
               <a:rPr lang="en-US" smtClean="0"/>
-              <a:t>3/1/2026</a:t>
+              <a:t>3/2/2026</a:t>
             </a:fld>
             <a:endParaRPr lang="en-US"/>
           </a:p>
@@ -666,7 +665,7 @@
           <a:p>
             <a:fld id="{76FC17FB-DA9F-457F-9F52-1E6CF5688C4E}" type="datetimeFigureOut">
               <a:rPr lang="en-US" smtClean="0"/>
-              <a:t>3/1/2026</a:t>
+              <a:t>3/2/2026</a:t>
             </a:fld>
             <a:endParaRPr lang="en-US"/>
           </a:p>
@@ -864,7 +863,7 @@
           <a:p>
             <a:fld id="{76FC17FB-DA9F-457F-9F52-1E6CF5688C4E}" type="datetimeFigureOut">
               <a:rPr lang="en-US" smtClean="0"/>
-              <a:t>3/1/2026</a:t>
+              <a:t>3/2/2026</a:t>
             </a:fld>
             <a:endParaRPr lang="en-US"/>
           </a:p>
@@ -1139,7 +1138,7 @@
           <a:p>
             <a:fld id="{76FC17FB-DA9F-457F-9F52-1E6CF5688C4E}" type="datetimeFigureOut">
               <a:rPr lang="en-US" smtClean="0"/>
-              <a:t>3/1/2026</a:t>
+              <a:t>3/2/2026</a:t>
             </a:fld>
             <a:endParaRPr lang="en-US"/>
           </a:p>
@@ -1404,7 +1403,7 @@
           <a:p>
             <a:fld id="{76FC17FB-DA9F-457F-9F52-1E6CF5688C4E}" type="datetimeFigureOut">
               <a:rPr lang="en-US" smtClean="0"/>
-              <a:t>3/1/2026</a:t>
+              <a:t>3/2/2026</a:t>
             </a:fld>
             <a:endParaRPr lang="en-US"/>
           </a:p>
@@ -1816,7 +1815,7 @@
           <a:p>
             <a:fld id="{76FC17FB-DA9F-457F-9F52-1E6CF5688C4E}" type="datetimeFigureOut">
               <a:rPr lang="en-US" smtClean="0"/>
-              <a:t>3/1/2026</a:t>
+              <a:t>3/2/2026</a:t>
             </a:fld>
             <a:endParaRPr lang="en-US"/>
           </a:p>
@@ -1957,7 +1956,7 @@
           <a:p>
             <a:fld id="{76FC17FB-DA9F-457F-9F52-1E6CF5688C4E}" type="datetimeFigureOut">
               <a:rPr lang="en-US" smtClean="0"/>
-              <a:t>3/1/2026</a:t>
+              <a:t>3/2/2026</a:t>
             </a:fld>
             <a:endParaRPr lang="en-US"/>
           </a:p>
@@ -2070,7 +2069,7 @@
           <a:p>
             <a:fld id="{76FC17FB-DA9F-457F-9F52-1E6CF5688C4E}" type="datetimeFigureOut">
               <a:rPr lang="en-US" smtClean="0"/>
-              <a:t>3/1/2026</a:t>
+              <a:t>3/2/2026</a:t>
             </a:fld>
             <a:endParaRPr lang="en-US"/>
           </a:p>
@@ -2381,7 +2380,7 @@
           <a:p>
             <a:fld id="{76FC17FB-DA9F-457F-9F52-1E6CF5688C4E}" type="datetimeFigureOut">
               <a:rPr lang="en-US" smtClean="0"/>
-              <a:t>3/1/2026</a:t>
+              <a:t>3/2/2026</a:t>
             </a:fld>
             <a:endParaRPr lang="en-US"/>
           </a:p>
@@ -2669,7 +2668,7 @@
           <a:p>
             <a:fld id="{76FC17FB-DA9F-457F-9F52-1E6CF5688C4E}" type="datetimeFigureOut">
               <a:rPr lang="en-US" smtClean="0"/>
-              <a:t>3/1/2026</a:t>
+              <a:t>3/2/2026</a:t>
             </a:fld>
             <a:endParaRPr lang="en-US"/>
           </a:p>
@@ -2910,7 +2909,7 @@
           <a:p>
             <a:fld id="{76FC17FB-DA9F-457F-9F52-1E6CF5688C4E}" type="datetimeFigureOut">
               <a:rPr lang="en-US" smtClean="0"/>
-              <a:t>3/1/2026</a:t>
+              <a:t>3/2/2026</a:t>
             </a:fld>
             <a:endParaRPr lang="en-US"/>
           </a:p>
@@ -4484,332 +4483,6 @@
 </p:sld>
 </file>
 
-<file path=ppt/slides/slide2.xml><?xml version="1.0" encoding="utf-8"?>
-<p:sld xmlns:a="http://schemas.openxmlformats.org/drawingml/2006/main" xmlns:r="http://schemas.openxmlformats.org/officeDocument/2006/relationships" xmlns:p="http://schemas.openxmlformats.org/presentationml/2006/main">
-  <p:cSld>
-    <p:spTree>
-      <p:nvGrpSpPr>
-        <p:cNvPr id="1" name="">
-          <a:extLst>
-            <a:ext uri="{FF2B5EF4-FFF2-40B4-BE49-F238E27FC236}">
-              <a16:creationId xmlns:a16="http://schemas.microsoft.com/office/drawing/2014/main" id="{99C855F0-1313-6B7D-A0C7-90E8FC1E8D7F}"/>
-            </a:ext>
-          </a:extLst>
-        </p:cNvPr>
-        <p:cNvGrpSpPr/>
-        <p:nvPr/>
-      </p:nvGrpSpPr>
-      <p:grpSpPr>
-        <a:xfrm>
-          <a:off x="0" y="0"/>
-          <a:ext cx="0" cy="0"/>
-          <a:chOff x="0" y="0"/>
-          <a:chExt cx="0" cy="0"/>
-        </a:xfrm>
-      </p:grpSpPr>
-      <p:pic>
-        <p:nvPicPr>
-          <p:cNvPr id="2" name="7576648115962">
-            <a:hlinkClick r:id="" action="ppaction://media"/>
-            <a:extLst>
-              <a:ext uri="{FF2B5EF4-FFF2-40B4-BE49-F238E27FC236}">
-                <a16:creationId xmlns:a16="http://schemas.microsoft.com/office/drawing/2014/main" id="{231FD6D7-C10F-8FCC-5BB7-808999D210E0}"/>
-              </a:ext>
-            </a:extLst>
-          </p:cNvPr>
-          <p:cNvPicPr>
-            <a:picLocks noChangeAspect="1"/>
-          </p:cNvPicPr>
-          <p:nvPr>
-            <a:videoFile r:link="rId2"/>
-            <p:extLst>
-              <p:ext uri="{DAA4B4D4-6D71-4841-9C94-3DE7FCFB9230}">
-                <p14:media xmlns:p14="http://schemas.microsoft.com/office/powerpoint/2010/main" r:embed="rId1"/>
-              </p:ext>
-            </p:extLst>
-          </p:nvPr>
-        </p:nvPicPr>
-        <p:blipFill>
-          <a:blip r:embed="rId4"/>
-          <a:stretch>
-            <a:fillRect/>
-          </a:stretch>
-        </p:blipFill>
-        <p:spPr>
-          <a:xfrm>
-            <a:off x="4167188" y="0"/>
-            <a:ext cx="3857625" cy="6858000"/>
-          </a:xfrm>
-          <a:prstGeom prst="rect">
-            <a:avLst/>
-          </a:prstGeom>
-        </p:spPr>
-      </p:pic>
-      <p:sp>
-        <p:nvSpPr>
-          <p:cNvPr id="3" name="Rectangle: Top Corners Rounded 2">
-            <a:extLst>
-              <a:ext uri="{FF2B5EF4-FFF2-40B4-BE49-F238E27FC236}">
-                <a16:creationId xmlns:a16="http://schemas.microsoft.com/office/drawing/2014/main" id="{9278558C-7C85-475F-A2D9-321CAA0BD7BC}"/>
-              </a:ext>
-            </a:extLst>
-          </p:cNvPr>
-          <p:cNvSpPr/>
-          <p:nvPr/>
-        </p:nvSpPr>
-        <p:spPr>
-          <a:xfrm rot="16200000">
-            <a:off x="-327649" y="2158566"/>
-            <a:ext cx="5055605" cy="3258790"/>
-          </a:xfrm>
-          <a:prstGeom prst="round2SameRect">
-            <a:avLst/>
-          </a:prstGeom>
-        </p:spPr>
-        <p:style>
-          <a:lnRef idx="2">
-            <a:schemeClr val="accent1">
-              <a:shade val="15000"/>
-            </a:schemeClr>
-          </a:lnRef>
-          <a:fillRef idx="1">
-            <a:schemeClr val="accent1"/>
-          </a:fillRef>
-          <a:effectRef idx="0">
-            <a:schemeClr val="accent1"/>
-          </a:effectRef>
-          <a:fontRef idx="minor">
-            <a:schemeClr val="lt1"/>
-          </a:fontRef>
-        </p:style>
-        <p:txBody>
-          <a:bodyPr rtlCol="0" anchor="ctr"/>
-          <a:lstStyle/>
-          <a:p>
-            <a:pPr algn="ctr"/>
-            <a:r>
-              <a:rPr lang="en-US" dirty="0"/>
-              <a:t>12345678910</a:t>
-            </a:r>
-          </a:p>
-        </p:txBody>
-      </p:sp>
-    </p:spTree>
-    <p:extLst>
-      <p:ext uri="{BB962C8B-B14F-4D97-AF65-F5344CB8AC3E}">
-        <p14:creationId xmlns:p14="http://schemas.microsoft.com/office/powerpoint/2010/main" val="1329382730"/>
-      </p:ext>
-    </p:extLst>
-  </p:cSld>
-  <p:clrMapOvr>
-    <a:masterClrMapping/>
-  </p:clrMapOvr>
-  <mc:AlternateContent xmlns:mc="http://schemas.openxmlformats.org/markup-compatibility/2006" xmlns:p14="http://schemas.microsoft.com/office/powerpoint/2010/main">
-    <mc:Choice Requires="p14">
-      <p:transition spd="slow" p14:dur="1500">
-        <p:split orient="vert"/>
-      </p:transition>
-    </mc:Choice>
-    <mc:Fallback xmlns="">
-      <p:transition spd="slow">
-        <p:split orient="vert"/>
-      </p:transition>
-    </mc:Fallback>
-  </mc:AlternateContent>
-  <p:timing>
-    <p:tnLst>
-      <p:par>
-        <p:cTn id="1" dur="indefinite" restart="never" nodeType="tmRoot">
-          <p:childTnLst>
-            <p:seq concurrent="1" nextAc="seek">
-              <p:cTn id="2" dur="indefinite" nodeType="mainSeq">
-                <p:childTnLst>
-                  <p:par>
-                    <p:cTn id="3" fill="hold">
-                      <p:stCondLst>
-                        <p:cond delay="indefinite"/>
-                      </p:stCondLst>
-                      <p:childTnLst>
-                        <p:par>
-                          <p:cTn id="4" fill="hold">
-                            <p:stCondLst>
-                              <p:cond delay="0"/>
-                            </p:stCondLst>
-                            <p:childTnLst>
-                              <p:par>
-                                <p:cTn id="5" presetID="1" presetClass="mediacall" presetSubtype="0" fill="hold" nodeType="clickEffect">
-                                  <p:stCondLst>
-                                    <p:cond delay="0"/>
-                                  </p:stCondLst>
-                                  <p:childTnLst>
-                                    <p:cmd type="call" cmd="playFrom(0.0)">
-                                      <p:cBhvr>
-                                        <p:cTn id="6" dur="7840" fill="hold"/>
-                                        <p:tgtEl>
-                                          <p:spTgt spid="2"/>
-                                        </p:tgtEl>
-                                      </p:cBhvr>
-                                    </p:cmd>
-                                  </p:childTnLst>
-                                </p:cTn>
-                              </p:par>
-                            </p:childTnLst>
-                          </p:cTn>
-                        </p:par>
-                      </p:childTnLst>
-                    </p:cTn>
-                  </p:par>
-                  <p:par>
-                    <p:cTn id="7" fill="hold">
-                      <p:stCondLst>
-                        <p:cond delay="indefinite"/>
-                      </p:stCondLst>
-                      <p:childTnLst>
-                        <p:par>
-                          <p:cTn id="8" fill="hold">
-                            <p:stCondLst>
-                              <p:cond delay="0"/>
-                            </p:stCondLst>
-                            <p:childTnLst>
-                              <p:par>
-                                <p:cTn id="9" presetID="22" presetClass="entr" presetSubtype="4" fill="hold" grpId="0" nodeType="clickEffect">
-                                  <p:stCondLst>
-                                    <p:cond delay="0"/>
-                                  </p:stCondLst>
-                                  <p:childTnLst>
-                                    <p:set>
-                                      <p:cBhvr>
-                                        <p:cTn id="10" dur="1" fill="hold">
-                                          <p:stCondLst>
-                                            <p:cond delay="0"/>
-                                          </p:stCondLst>
-                                        </p:cTn>
-                                        <p:tgtEl>
-                                          <p:spTgt spid="3"/>
-                                        </p:tgtEl>
-                                        <p:attrNameLst>
-                                          <p:attrName>style.visibility</p:attrName>
-                                        </p:attrNameLst>
-                                      </p:cBhvr>
-                                      <p:to>
-                                        <p:strVal val="visible"/>
-                                      </p:to>
-                                    </p:set>
-                                    <p:animEffect transition="in" filter="wipe(down)">
-                                      <p:cBhvr>
-                                        <p:cTn id="11" dur="500"/>
-                                        <p:tgtEl>
-                                          <p:spTgt spid="3"/>
-                                        </p:tgtEl>
-                                      </p:cBhvr>
-                                    </p:animEffect>
-                                  </p:childTnLst>
-                                </p:cTn>
-                              </p:par>
-                            </p:childTnLst>
-                          </p:cTn>
-                        </p:par>
-                      </p:childTnLst>
-                    </p:cTn>
-                  </p:par>
-                </p:childTnLst>
-              </p:cTn>
-              <p:prevCondLst>
-                <p:cond evt="onPrev" delay="0">
-                  <p:tgtEl>
-                    <p:sldTgt/>
-                  </p:tgtEl>
-                </p:cond>
-              </p:prevCondLst>
-              <p:nextCondLst>
-                <p:cond evt="onNext" delay="0">
-                  <p:tgtEl>
-                    <p:sldTgt/>
-                  </p:tgtEl>
-                </p:cond>
-              </p:nextCondLst>
-            </p:seq>
-            <p:video>
-              <p:cMediaNode vol="80000">
-                <p:cTn id="12" fill="hold" display="0">
-                  <p:stCondLst>
-                    <p:cond delay="indefinite"/>
-                  </p:stCondLst>
-                </p:cTn>
-                <p:tgtEl>
-                  <p:spTgt spid="2"/>
-                </p:tgtEl>
-              </p:cMediaNode>
-            </p:video>
-            <p:seq concurrent="1" nextAc="seek">
-              <p:cTn id="13" restart="whenNotActive" fill="hold" evtFilter="cancelBubble" nodeType="interactiveSeq">
-                <p:stCondLst>
-                  <p:cond evt="onClick" delay="0">
-                    <p:tgtEl>
-                      <p:spTgt spid="2"/>
-                    </p:tgtEl>
-                  </p:cond>
-                </p:stCondLst>
-                <p:endSync evt="end" delay="0">
-                  <p:rtn val="all"/>
-                </p:endSync>
-                <p:childTnLst>
-                  <p:par>
-                    <p:cTn id="14" fill="hold">
-                      <p:stCondLst>
-                        <p:cond delay="0"/>
-                      </p:stCondLst>
-                      <p:childTnLst>
-                        <p:par>
-                          <p:cTn id="15" fill="hold">
-                            <p:stCondLst>
-                              <p:cond delay="0"/>
-                            </p:stCondLst>
-                            <p:childTnLst>
-                              <p:par>
-                                <p:cTn id="16" presetID="2" presetClass="mediacall" presetSubtype="0" fill="hold" nodeType="clickEffect">
-                                  <p:stCondLst>
-                                    <p:cond delay="0"/>
-                                  </p:stCondLst>
-                                  <p:childTnLst>
-                                    <p:cmd type="call" cmd="togglePause">
-                                      <p:cBhvr>
-                                        <p:cTn id="17" dur="1" fill="hold"/>
-                                        <p:tgtEl>
-                                          <p:spTgt spid="2"/>
-                                        </p:tgtEl>
-                                      </p:cBhvr>
-                                    </p:cmd>
-                                  </p:childTnLst>
-                                </p:cTn>
-                              </p:par>
-                            </p:childTnLst>
-                          </p:cTn>
-                        </p:par>
-                      </p:childTnLst>
-                    </p:cTn>
-                  </p:par>
-                </p:childTnLst>
-              </p:cTn>
-              <p:nextCondLst>
-                <p:cond evt="onClick" delay="0">
-                  <p:tgtEl>
-                    <p:spTgt spid="2"/>
-                  </p:tgtEl>
-                </p:cond>
-              </p:nextCondLst>
-            </p:seq>
-          </p:childTnLst>
-        </p:cTn>
-      </p:par>
-    </p:tnLst>
-    <p:bldLst>
-      <p:bldP spid="3" grpId="0" animBg="1"/>
-    </p:bldLst>
-  </p:timing>
-</p:sld>
-</file>
-
 <file path=ppt/theme/theme1.xml><?xml version="1.0" encoding="utf-8"?>
 <a:theme xmlns:a="http://schemas.openxmlformats.org/drawingml/2006/main" name="Office Theme">
   <a:themeElements>

</xml_diff>